<commit_message>
Update R&D Weekly Update deck
Co-Authored-By: Claude Sonnet 5 <noreply@anthropic.com>
Claude-Session: https://claude.ai/code/session_013aVfofQf3WHyjQ8EXDYues
</commit_message>
<xml_diff>
--- a/reports/R&D_Weekly_Update.pptx
+++ b/reports/R&D_Weekly_Update.pptx
@@ -5,7 +5,7 @@
     <p:sldMasterId id="2147483648" r:id="rId1"/>
   </p:sldMasterIdLst>
   <p:notesMasterIdLst>
-    <p:notesMasterId r:id="rId8"/>
+    <p:notesMasterId r:id="rId10"/>
   </p:notesMasterIdLst>
   <p:sldIdLst>
     <p:sldId id="256" r:id="rId2"/>
@@ -14,6 +14,8 @@
     <p:sldId id="259" r:id="rId5"/>
     <p:sldId id="260" r:id="rId6"/>
     <p:sldId id="261" r:id="rId7"/>
+    <p:sldId id="262" r:id="rId8"/>
+    <p:sldId id="263" r:id="rId9"/>
   </p:sldIdLst>
   <p:sldSz cx="18288000" cy="10287000"/>
   <p:notesSz cx="10287000" cy="18288000"/>
@@ -755,6 +757,180 @@
     <p:extLst>
       <p:ext uri="{BB962C8B-B14F-4D97-AF65-F5344CB8AC3E}">
         <p14:creationId xmlns:p14="http://schemas.microsoft.com/office/powerpoint/2010/main" val="280973723"/>
+      </p:ext>
+    </p:extLst>
+  </p:cSld>
+  <p:clrMapOvr>
+    <a:masterClrMapping/>
+  </p:clrMapOvr>
+</p:notes>
+</file>
+
+<file path=ppt/notesSlides/notesSlide7.xml><?xml version="1.0" encoding="utf-8"?>
+<p:notes xmlns:a="http://schemas.openxmlformats.org/drawingml/2006/main" xmlns:r="http://schemas.openxmlformats.org/officeDocument/2006/relationships" xmlns:p="http://schemas.openxmlformats.org/presentationml/2006/main">
+  <p:cSld>
+    <p:spTree>
+      <p:nvGrpSpPr>
+        <p:cNvPr id="1" name=""/>
+        <p:cNvGrpSpPr/>
+        <p:nvPr/>
+      </p:nvGrpSpPr>
+      <p:grpSpPr>
+        <a:xfrm>
+          <a:off x="0" y="0"/>
+          <a:ext cx="0" cy="0"/>
+          <a:chOff x="0" y="0"/>
+          <a:chExt cx="0" cy="0"/>
+        </a:xfrm>
+      </p:grpSpPr>
+      <p:sp>
+        <p:nvSpPr>
+          <p:cNvPr id="2" name="Slide Image Placeholder 1"/>
+          <p:cNvSpPr>
+            <a:spLocks noGrp="1" noRot="1" noChangeAspect="1"/>
+          </p:cNvSpPr>
+          <p:nvPr>
+            <p:ph type="sldImg"/>
+          </p:nvPr>
+        </p:nvSpPr>
+        <p:spPr/>
+      </p:sp>
+      <p:sp>
+        <p:nvSpPr>
+          <p:cNvPr id="3" name="Notes Placeholder 2"/>
+          <p:cNvSpPr>
+            <a:spLocks noGrp="1"/>
+          </p:cNvSpPr>
+          <p:nvPr>
+            <p:ph type="body" idx="1"/>
+          </p:nvPr>
+        </p:nvSpPr>
+        <p:spPr/>
+        <p:txBody>
+          <a:bodyPr/>
+          <a:lstStyle/>
+          <a:p>
+            <a:r>
+              <a:rPr lang="en-US" dirty="0"/>
+              <a:t>Snapshot of all three projects — status, this week's work, next step.</a:t>
+            </a:r>
+          </a:p>
+        </p:txBody>
+      </p:sp>
+      <p:sp>
+        <p:nvSpPr>
+          <p:cNvPr id="4" name="Slide Number Placeholder 3"/>
+          <p:cNvSpPr>
+            <a:spLocks noGrp="1"/>
+          </p:cNvSpPr>
+          <p:nvPr>
+            <p:ph type="sldNum" sz="quarter" idx="10"/>
+          </p:nvPr>
+        </p:nvSpPr>
+        <p:spPr/>
+        <p:txBody>
+          <a:bodyPr/>
+          <a:lstStyle/>
+          <a:p>
+            <a:fld id="{F7021451-1387-4CA6-816F-3879F97B5CBC}" type="slidenum">
+              <a:rPr lang="en-US"/>
+              <a:t>7</a:t>
+            </a:fld>
+            <a:endParaRPr lang="en-US"/>
+          </a:p>
+        </p:txBody>
+      </p:sp>
+    </p:spTree>
+    <p:extLst>
+      <p:ext uri="{BB962C8B-B14F-4D97-AF65-F5344CB8AC3E}">
+        <p14:creationId xmlns:p14="http://schemas.microsoft.com/office/powerpoint/2010/main" val="689448499"/>
+      </p:ext>
+    </p:extLst>
+  </p:cSld>
+  <p:clrMapOvr>
+    <a:masterClrMapping/>
+  </p:clrMapOvr>
+</p:notes>
+</file>
+
+<file path=ppt/notesSlides/notesSlide8.xml><?xml version="1.0" encoding="utf-8"?>
+<p:notes xmlns:a="http://schemas.openxmlformats.org/drawingml/2006/main" xmlns:r="http://schemas.openxmlformats.org/officeDocument/2006/relationships" xmlns:p="http://schemas.openxmlformats.org/presentationml/2006/main">
+  <p:cSld>
+    <p:spTree>
+      <p:nvGrpSpPr>
+        <p:cNvPr id="1" name=""/>
+        <p:cNvGrpSpPr/>
+        <p:nvPr/>
+      </p:nvGrpSpPr>
+      <p:grpSpPr>
+        <a:xfrm>
+          <a:off x="0" y="0"/>
+          <a:ext cx="0" cy="0"/>
+          <a:chOff x="0" y="0"/>
+          <a:chExt cx="0" cy="0"/>
+        </a:xfrm>
+      </p:grpSpPr>
+      <p:sp>
+        <p:nvSpPr>
+          <p:cNvPr id="2" name="Slide Image Placeholder 1"/>
+          <p:cNvSpPr>
+            <a:spLocks noGrp="1" noRot="1" noChangeAspect="1"/>
+          </p:cNvSpPr>
+          <p:nvPr>
+            <p:ph type="sldImg"/>
+          </p:nvPr>
+        </p:nvSpPr>
+        <p:spPr/>
+      </p:sp>
+      <p:sp>
+        <p:nvSpPr>
+          <p:cNvPr id="3" name="Notes Placeholder 2"/>
+          <p:cNvSpPr>
+            <a:spLocks noGrp="1"/>
+          </p:cNvSpPr>
+          <p:nvPr>
+            <p:ph type="body" idx="1"/>
+          </p:nvPr>
+        </p:nvSpPr>
+        <p:spPr/>
+        <p:txBody>
+          <a:bodyPr/>
+          <a:lstStyle/>
+          <a:p>
+            <a:r>
+              <a:rPr lang="en-US" dirty="0"/>
+              <a:t>Snapshot of all three projects — status, this week's work, next step.</a:t>
+            </a:r>
+          </a:p>
+        </p:txBody>
+      </p:sp>
+      <p:sp>
+        <p:nvSpPr>
+          <p:cNvPr id="4" name="Slide Number Placeholder 3"/>
+          <p:cNvSpPr>
+            <a:spLocks noGrp="1"/>
+          </p:cNvSpPr>
+          <p:nvPr>
+            <p:ph type="sldNum" sz="quarter" idx="10"/>
+          </p:nvPr>
+        </p:nvSpPr>
+        <p:spPr/>
+        <p:txBody>
+          <a:bodyPr/>
+          <a:lstStyle/>
+          <a:p>
+            <a:fld id="{F7021451-1387-4CA6-816F-3879F97B5CBC}" type="slidenum">
+              <a:rPr lang="en-US"/>
+              <a:t>8</a:t>
+            </a:fld>
+            <a:endParaRPr lang="en-US"/>
+          </a:p>
+        </p:txBody>
+      </p:sp>
+    </p:spTree>
+    <p:extLst>
+      <p:ext uri="{BB962C8B-B14F-4D97-AF65-F5344CB8AC3E}">
+        <p14:creationId xmlns:p14="http://schemas.microsoft.com/office/powerpoint/2010/main" val="520767634"/>
       </p:ext>
     </p:extLst>
   </p:cSld>
@@ -7861,14 +8037,14 @@
           <p:nvPr>
             <p:extLst>
               <p:ext uri="{D42A27DB-BD31-4B8C-83A1-F6EECF244321}">
-                <p14:modId xmlns:p14="http://schemas.microsoft.com/office/powerpoint/2010/main" val="961892258"/>
+                <p14:modId xmlns:p14="http://schemas.microsoft.com/office/powerpoint/2010/main" val="1457762451"/>
               </p:ext>
             </p:extLst>
           </p:nvPr>
         </p:nvGraphicFramePr>
         <p:xfrm>
           <a:off x="840906" y="3924523"/>
-          <a:ext cx="10610865" cy="1874288"/>
+          <a:ext cx="13310523" cy="2226194"/>
         </p:xfrm>
         <a:graphic>
           <a:graphicData uri="http://schemas.openxmlformats.org/drawingml/2006/table">
@@ -7877,28 +8053,28 @@
                 <a:tableStyleId>{93296810-A885-4BE3-A3E7-6D5BEEA58F35}</a:tableStyleId>
               </a:tblPr>
               <a:tblGrid>
-                <a:gridCol w="1452351">
+                <a:gridCol w="1821864">
                   <a:extLst>
                     <a:ext uri="{9D8B030D-6E8A-4147-A177-3AD203B41FA5}">
                       <a16:colId xmlns:a16="http://schemas.microsoft.com/office/drawing/2014/main" val="3809572241"/>
                     </a:ext>
                   </a:extLst>
                 </a:gridCol>
-                <a:gridCol w="2873829">
+                <a:gridCol w="3605000">
                   <a:extLst>
                     <a:ext uri="{9D8B030D-6E8A-4147-A177-3AD203B41FA5}">
                       <a16:colId xmlns:a16="http://schemas.microsoft.com/office/drawing/2014/main" val="1640512054"/>
                     </a:ext>
                   </a:extLst>
                 </a:gridCol>
-                <a:gridCol w="3570514">
+                <a:gridCol w="4478938">
                   <a:extLst>
                     <a:ext uri="{9D8B030D-6E8A-4147-A177-3AD203B41FA5}">
                       <a16:colId xmlns:a16="http://schemas.microsoft.com/office/drawing/2014/main" val="3561229697"/>
                     </a:ext>
                   </a:extLst>
                 </a:gridCol>
-                <a:gridCol w="2714171">
+                <a:gridCol w="3404721">
                   <a:extLst>
                     <a:ext uri="{9D8B030D-6E8A-4147-A177-3AD203B41FA5}">
                       <a16:colId xmlns:a16="http://schemas.microsoft.com/office/drawing/2014/main" val="1366842677"/>
@@ -8667,7 +8843,7 @@
                         </a:spcAft>
                       </a:pPr>
                       <a:r>
-                        <a:rPr lang="en-US" sz="2000" i="1">
+                        <a:rPr lang="en-US" sz="2000" i="1" dirty="0">
                           <a:solidFill>
                             <a:srgbClr val="111111"/>
                           </a:solidFill>
@@ -8676,9 +8852,9 @@
                           <a:ea typeface="Cambria" panose="02040503050406030204" pitchFamily="18" charset="0"/>
                           <a:cs typeface="Cambria" panose="02040503050406030204" pitchFamily="18" charset="0"/>
                         </a:rPr>
-                        <a:t>(speaking softly, quietly)</a:t>
+                        <a:t>(speaking very quietly)</a:t>
                       </a:r>
-                      <a:endParaRPr lang="en-US" sz="2000">
+                      <a:endParaRPr lang="en-US" sz="2000" dirty="0">
                         <a:solidFill>
                           <a:srgbClr val="111111"/>
                         </a:solidFill>
@@ -8748,18 +8924,18 @@
                         </a:spcAft>
                       </a:pPr>
                       <a:r>
-                        <a:rPr lang="en-US" sz="2000" i="1">
+                        <a:rPr lang="en-US" sz="2000" i="1" dirty="0">
                           <a:solidFill>
                             <a:srgbClr val="111111"/>
                           </a:solidFill>
                           <a:effectLst/>
                           <a:latin typeface="Cambria" panose="02040503050406030204" pitchFamily="18" charset="0"/>
                           <a:ea typeface="Cambria" panose="02040503050406030204" pitchFamily="18" charset="0"/>
-                          <a:cs typeface="Cambria" panose="02040503050406030204" pitchFamily="18" charset="0"/>
+                          <a:cs typeface="Khmer OS System" panose="02000500000000020004" pitchFamily="2" charset="0"/>
                         </a:rPr>
-                        <a:t>(speaking at a normal volume)</a:t>
+                        <a:t>-</a:t>
                       </a:r>
-                      <a:endParaRPr lang="en-US" sz="2000">
+                      <a:endParaRPr lang="en-US" sz="2000" dirty="0">
                         <a:solidFill>
                           <a:srgbClr val="111111"/>
                         </a:solidFill>
@@ -8829,7 +9005,7 @@
                         </a:spcAft>
                       </a:pPr>
                       <a:r>
-                        <a:rPr lang="en-US" sz="2000" i="1">
+                        <a:rPr lang="en-US" sz="2000" i="1" dirty="0">
                           <a:solidFill>
                             <a:srgbClr val="111111"/>
                           </a:solidFill>
@@ -8838,9 +9014,9 @@
                           <a:ea typeface="Cambria" panose="02040503050406030204" pitchFamily="18" charset="0"/>
                           <a:cs typeface="Cambria" panose="02040503050406030204" pitchFamily="18" charset="0"/>
                         </a:rPr>
-                        <a:t>(speaking loudly)</a:t>
+                        <a:t>(speaking extremely loudly, at full volume)</a:t>
                       </a:r>
-                      <a:endParaRPr lang="en-US" sz="2000">
+                      <a:endParaRPr lang="en-US" sz="2000" dirty="0">
                         <a:solidFill>
                           <a:srgbClr val="111111"/>
                         </a:solidFill>
@@ -8998,7 +9174,7 @@
                         </a:spcAft>
                       </a:pPr>
                       <a:r>
-                        <a:rPr lang="en-US" sz="2000" i="1">
+                        <a:rPr lang="en-US" sz="2000" i="1" dirty="0">
                           <a:solidFill>
                             <a:srgbClr val="111111"/>
                           </a:solidFill>
@@ -9007,9 +9183,9 @@
                           <a:ea typeface="Cambria" panose="02040503050406030204" pitchFamily="18" charset="0"/>
                           <a:cs typeface="Cambria" panose="02040503050406030204" pitchFamily="18" charset="0"/>
                         </a:rPr>
-                        <a:t>(speaking slowly)</a:t>
+                        <a:t>(speaking very slowly, and deliberately)</a:t>
                       </a:r>
-                      <a:endParaRPr lang="en-US" sz="2000">
+                      <a:endParaRPr lang="en-US" sz="2000" dirty="0">
                         <a:solidFill>
                           <a:srgbClr val="111111"/>
                         </a:solidFill>
@@ -9366,10 +9542,1163 @@
           </a:p>
         </p:txBody>
       </p:sp>
+      <p:sp>
+        <p:nvSpPr>
+          <p:cNvPr id="9" name="Text 15">
+            <a:extLst>
+              <a:ext uri="{FF2B5EF4-FFF2-40B4-BE49-F238E27FC236}">
+                <a16:creationId xmlns:a16="http://schemas.microsoft.com/office/drawing/2014/main" id="{59476064-A6EA-4F04-87A9-61C32A65E299}"/>
+              </a:ext>
+            </a:extLst>
+          </p:cNvPr>
+          <p:cNvSpPr/>
+          <p:nvPr/>
+        </p:nvSpPr>
+        <p:spPr>
+          <a:xfrm>
+            <a:off x="688509" y="9143301"/>
+            <a:ext cx="9869714" cy="389016"/>
+          </a:xfrm>
+          <a:prstGeom prst="rect">
+            <a:avLst/>
+          </a:prstGeom>
+          <a:noFill/>
+          <a:ln/>
+        </p:spPr>
+        <p:txBody>
+          <a:bodyPr wrap="square" lIns="25400" tIns="25400" rIns="25400" bIns="25400" rtlCol="0" anchor="t">
+            <a:noAutofit/>
+          </a:bodyPr>
+          <a:lstStyle/>
+          <a:p>
+            <a:pPr algn="just">
+              <a:lnSpc>
+                <a:spcPct val="114853"/>
+              </a:lnSpc>
+            </a:pPr>
+            <a:r>
+              <a:rPr lang="en-US" sz="2000" i="1" dirty="0">
+                <a:solidFill>
+                  <a:schemeClr val="bg2">
+                    <a:lumMod val="75000"/>
+                  </a:schemeClr>
+                </a:solidFill>
+                <a:latin typeface="Cambria" panose="02040503050406030204" pitchFamily="18" charset="0"/>
+                <a:ea typeface="Cambria" panose="02040503050406030204" pitchFamily="18" charset="0"/>
+              </a:rPr>
+              <a:t>Sample audio can be listened </a:t>
+            </a:r>
+            <a:r>
+              <a:rPr lang="en-US" sz="2000" i="1" dirty="0">
+                <a:solidFill>
+                  <a:schemeClr val="bg2">
+                    <a:lumMod val="75000"/>
+                  </a:schemeClr>
+                </a:solidFill>
+                <a:latin typeface="Cambria" panose="02040503050406030204" pitchFamily="18" charset="0"/>
+                <a:ea typeface="Cambria" panose="02040503050406030204" pitchFamily="18" charset="0"/>
+                <a:hlinkClick r:id="rId3"/>
+              </a:rPr>
+              <a:t>here</a:t>
+            </a:r>
+            <a:endParaRPr lang="en-US" sz="2000" i="1" dirty="0">
+              <a:solidFill>
+                <a:schemeClr val="bg2">
+                  <a:lumMod val="75000"/>
+                </a:schemeClr>
+              </a:solidFill>
+              <a:latin typeface="Cambria" panose="02040503050406030204" pitchFamily="18" charset="0"/>
+              <a:ea typeface="Cambria" panose="02040503050406030204" pitchFamily="18" charset="0"/>
+            </a:endParaRPr>
+          </a:p>
+        </p:txBody>
+      </p:sp>
     </p:spTree>
     <p:extLst>
       <p:ext uri="{BB962C8B-B14F-4D97-AF65-F5344CB8AC3E}">
         <p14:creationId xmlns:p14="http://schemas.microsoft.com/office/powerpoint/2010/main" val="15913427"/>
+      </p:ext>
+    </p:extLst>
+  </p:cSld>
+  <p:clrMapOvr>
+    <a:masterClrMapping/>
+  </p:clrMapOvr>
+</p:sld>
+</file>
+
+<file path=ppt/slides/slide7.xml><?xml version="1.0" encoding="utf-8"?>
+<p:sld xmlns:a="http://schemas.openxmlformats.org/drawingml/2006/main" xmlns:r="http://schemas.openxmlformats.org/officeDocument/2006/relationships" xmlns:p="http://schemas.openxmlformats.org/presentationml/2006/main">
+  <p:cSld>
+    <p:bg>
+      <p:bgPr>
+        <a:solidFill>
+          <a:srgbClr val="FAF8F4"/>
+        </a:solidFill>
+        <a:effectLst/>
+      </p:bgPr>
+    </p:bg>
+    <p:spTree>
+      <p:nvGrpSpPr>
+        <p:cNvPr id="1" name=""/>
+        <p:cNvGrpSpPr/>
+        <p:nvPr/>
+      </p:nvGrpSpPr>
+      <p:grpSpPr>
+        <a:xfrm>
+          <a:off x="0" y="0"/>
+          <a:ext cx="0" cy="0"/>
+          <a:chOff x="0" y="0"/>
+          <a:chExt cx="0" cy="0"/>
+        </a:xfrm>
+      </p:grpSpPr>
+      <p:grpSp>
+        <p:nvGrpSpPr>
+          <p:cNvPr id="3" name="Group 2">
+            <a:extLst>
+              <a:ext uri="{FF2B5EF4-FFF2-40B4-BE49-F238E27FC236}">
+                <a16:creationId xmlns:a16="http://schemas.microsoft.com/office/drawing/2014/main" id="{CE41674B-3A28-4A10-BE8B-919C3E3A4D31}"/>
+              </a:ext>
+            </a:extLst>
+          </p:cNvPr>
+          <p:cNvGrpSpPr/>
+          <p:nvPr/>
+        </p:nvGrpSpPr>
+        <p:grpSpPr>
+          <a:xfrm>
+            <a:off x="688508" y="832167"/>
+            <a:ext cx="13622578" cy="867471"/>
+            <a:chOff x="5550794" y="437377"/>
+            <a:chExt cx="11230589" cy="867471"/>
+          </a:xfrm>
+        </p:grpSpPr>
+        <p:sp>
+          <p:nvSpPr>
+            <p:cNvPr id="36" name="Text 10">
+              <a:extLst>
+                <a:ext uri="{FF2B5EF4-FFF2-40B4-BE49-F238E27FC236}">
+                  <a16:creationId xmlns:a16="http://schemas.microsoft.com/office/drawing/2014/main" id="{653710F3-73F0-4CC1-9253-3E1A5D14AAF0}"/>
+                </a:ext>
+              </a:extLst>
+            </p:cNvPr>
+            <p:cNvSpPr/>
+            <p:nvPr/>
+          </p:nvSpPr>
+          <p:spPr>
+            <a:xfrm>
+              <a:off x="5550794" y="437377"/>
+              <a:ext cx="11230589" cy="820856"/>
+            </a:xfrm>
+            <a:prstGeom prst="rect">
+              <a:avLst/>
+            </a:prstGeom>
+            <a:noFill/>
+            <a:ln/>
+          </p:spPr>
+          <p:txBody>
+            <a:bodyPr wrap="square" lIns="25400" tIns="25400" rIns="25400" bIns="25400" rtlCol="0" anchor="t">
+              <a:noAutofit/>
+            </a:bodyPr>
+            <a:lstStyle/>
+            <a:p>
+              <a:pPr marL="0" indent="0" algn="l">
+                <a:lnSpc>
+                  <a:spcPct val="93867"/>
+                </a:lnSpc>
+                <a:buNone/>
+              </a:pPr>
+              <a:r>
+                <a:rPr lang="en-US" sz="4800" b="1" kern="0" spc="-36" dirty="0">
+                  <a:solidFill>
+                    <a:srgbClr val="0B5852"/>
+                  </a:solidFill>
+                  <a:latin typeface="Georgia" panose="02040502050405020303" pitchFamily="18" charset="0"/>
+                  <a:ea typeface="Barlow Condensed" pitchFamily="34" charset="-122"/>
+                </a:rPr>
+                <a:t>Controlling Pitch Modulation</a:t>
+              </a:r>
+              <a:endParaRPr lang="en-US" sz="4800" b="1" dirty="0">
+                <a:latin typeface="Georgia" panose="02040502050405020303" pitchFamily="18" charset="0"/>
+              </a:endParaRPr>
+            </a:p>
+          </p:txBody>
+        </p:sp>
+        <p:sp>
+          <p:nvSpPr>
+            <p:cNvPr id="48" name="Shape 1">
+              <a:extLst>
+                <a:ext uri="{FF2B5EF4-FFF2-40B4-BE49-F238E27FC236}">
+                  <a16:creationId xmlns:a16="http://schemas.microsoft.com/office/drawing/2014/main" id="{D062D97B-2B0C-4CB5-8535-9E819970BA10}"/>
+                </a:ext>
+              </a:extLst>
+            </p:cNvPr>
+            <p:cNvSpPr/>
+            <p:nvPr/>
+          </p:nvSpPr>
+          <p:spPr>
+            <a:xfrm>
+              <a:off x="5550794" y="1258232"/>
+              <a:ext cx="7593708" cy="46616"/>
+            </a:xfrm>
+            <a:prstGeom prst="rect">
+              <a:avLst/>
+            </a:prstGeom>
+            <a:solidFill>
+              <a:srgbClr val="0B5852"/>
+            </a:solidFill>
+            <a:ln/>
+          </p:spPr>
+        </p:sp>
+      </p:grpSp>
+      <p:sp>
+        <p:nvSpPr>
+          <p:cNvPr id="87" name="Shape 0">
+            <a:extLst>
+              <a:ext uri="{FF2B5EF4-FFF2-40B4-BE49-F238E27FC236}">
+                <a16:creationId xmlns:a16="http://schemas.microsoft.com/office/drawing/2014/main" id="{D0E0CC4D-0857-4350-BEF7-5F0684DE29AA}"/>
+              </a:ext>
+            </a:extLst>
+          </p:cNvPr>
+          <p:cNvSpPr/>
+          <p:nvPr/>
+        </p:nvSpPr>
+        <p:spPr>
+          <a:xfrm>
+            <a:off x="0" y="9897984"/>
+            <a:ext cx="18288000" cy="389016"/>
+          </a:xfrm>
+          <a:prstGeom prst="rect">
+            <a:avLst/>
+          </a:prstGeom>
+          <a:solidFill>
+            <a:srgbClr val="083B37"/>
+          </a:solidFill>
+          <a:ln/>
+        </p:spPr>
+      </p:sp>
+      <p:sp>
+        <p:nvSpPr>
+          <p:cNvPr id="11" name="Text 15">
+            <a:extLst>
+              <a:ext uri="{FF2B5EF4-FFF2-40B4-BE49-F238E27FC236}">
+                <a16:creationId xmlns:a16="http://schemas.microsoft.com/office/drawing/2014/main" id="{FECC5527-4521-4688-99AA-6391B4886929}"/>
+              </a:ext>
+            </a:extLst>
+          </p:cNvPr>
+          <p:cNvSpPr/>
+          <p:nvPr/>
+        </p:nvSpPr>
+        <p:spPr>
+          <a:xfrm>
+            <a:off x="840907" y="2120491"/>
+            <a:ext cx="15049063" cy="1487420"/>
+          </a:xfrm>
+          <a:prstGeom prst="rect">
+            <a:avLst/>
+          </a:prstGeom>
+          <a:noFill/>
+          <a:ln/>
+        </p:spPr>
+        <p:txBody>
+          <a:bodyPr wrap="square" lIns="25400" tIns="25400" rIns="25400" bIns="25400" rtlCol="0" anchor="t">
+            <a:normAutofit/>
+          </a:bodyPr>
+          <a:lstStyle/>
+          <a:p>
+            <a:pPr algn="just">
+              <a:lnSpc>
+                <a:spcPct val="114853"/>
+              </a:lnSpc>
+            </a:pPr>
+            <a:r>
+              <a:rPr lang="en-US" sz="2000" dirty="0">
+                <a:solidFill>
+                  <a:schemeClr val="bg2">
+                    <a:lumMod val="25000"/>
+                  </a:schemeClr>
+                </a:solidFill>
+                <a:latin typeface="Cambria" panose="02040503050406030204" pitchFamily="18" charset="0"/>
+                <a:ea typeface="Cambria" panose="02040503050406030204" pitchFamily="18" charset="0"/>
+              </a:rPr>
+              <a:t>The key to making </a:t>
+            </a:r>
+            <a:r>
+              <a:rPr lang="en-US" sz="2000" dirty="0" err="1">
+                <a:solidFill>
+                  <a:schemeClr val="bg2">
+                    <a:lumMod val="25000"/>
+                  </a:schemeClr>
+                </a:solidFill>
+                <a:latin typeface="Cambria" panose="02040503050406030204" pitchFamily="18" charset="0"/>
+                <a:ea typeface="Cambria" panose="02040503050406030204" pitchFamily="18" charset="0"/>
+              </a:rPr>
+              <a:t>Smean</a:t>
+            </a:r>
+            <a:r>
+              <a:rPr lang="en-US" sz="2000" dirty="0">
+                <a:solidFill>
+                  <a:schemeClr val="bg2">
+                    <a:lumMod val="25000"/>
+                  </a:schemeClr>
+                </a:solidFill>
+                <a:latin typeface="Cambria" panose="02040503050406030204" pitchFamily="18" charset="0"/>
+                <a:ea typeface="Cambria" panose="02040503050406030204" pitchFamily="18" charset="0"/>
+              </a:rPr>
+              <a:t> TTS sound natural is controlling the pitch over time to add expression, depth, and emotional nuance. However, describing the expression, and depth does not reliably control how varied the voice generated by VoxCPM2 are. Therefore, we proposed another method of controlling modulation through reference clips.</a:t>
+            </a:r>
+          </a:p>
+          <a:p>
+            <a:pPr algn="just">
+              <a:lnSpc>
+                <a:spcPct val="114853"/>
+              </a:lnSpc>
+            </a:pPr>
+            <a:endParaRPr lang="en-US" sz="2000" dirty="0">
+              <a:solidFill>
+                <a:schemeClr val="bg2">
+                  <a:lumMod val="25000"/>
+                </a:schemeClr>
+              </a:solidFill>
+              <a:latin typeface="Cambria" panose="02040503050406030204" pitchFamily="18" charset="0"/>
+              <a:ea typeface="Cambria" panose="02040503050406030204" pitchFamily="18" charset="0"/>
+            </a:endParaRPr>
+          </a:p>
+        </p:txBody>
+      </p:sp>
+      <p:grpSp>
+        <p:nvGrpSpPr>
+          <p:cNvPr id="5" name="Group 4">
+            <a:extLst>
+              <a:ext uri="{FF2B5EF4-FFF2-40B4-BE49-F238E27FC236}">
+                <a16:creationId xmlns:a16="http://schemas.microsoft.com/office/drawing/2014/main" id="{17F11D0D-2113-47B9-AB0A-4D7BCCC8EED2}"/>
+              </a:ext>
+            </a:extLst>
+          </p:cNvPr>
+          <p:cNvGrpSpPr/>
+          <p:nvPr/>
+        </p:nvGrpSpPr>
+        <p:grpSpPr>
+          <a:xfrm>
+            <a:off x="688508" y="3950365"/>
+            <a:ext cx="6059330" cy="5457449"/>
+            <a:chOff x="9340515" y="1733968"/>
+            <a:chExt cx="6059330" cy="5457449"/>
+          </a:xfrm>
+        </p:grpSpPr>
+        <p:grpSp>
+          <p:nvGrpSpPr>
+            <p:cNvPr id="12" name="Group 11">
+              <a:extLst>
+                <a:ext uri="{FF2B5EF4-FFF2-40B4-BE49-F238E27FC236}">
+                  <a16:creationId xmlns:a16="http://schemas.microsoft.com/office/drawing/2014/main" id="{B21FE8D3-4D10-4197-B5E9-C2701BD675FA}"/>
+                </a:ext>
+              </a:extLst>
+            </p:cNvPr>
+            <p:cNvGrpSpPr/>
+            <p:nvPr/>
+          </p:nvGrpSpPr>
+          <p:grpSpPr>
+            <a:xfrm>
+              <a:off x="9340515" y="1733968"/>
+              <a:ext cx="6059330" cy="5056561"/>
+              <a:chOff x="11579560" y="1968091"/>
+              <a:chExt cx="4416619" cy="3685706"/>
+            </a:xfrm>
+          </p:grpSpPr>
+          <p:sp>
+            <p:nvSpPr>
+              <p:cNvPr id="13" name="Rectangle: Rounded Corners 12">
+                <a:extLst>
+                  <a:ext uri="{FF2B5EF4-FFF2-40B4-BE49-F238E27FC236}">
+                    <a16:creationId xmlns:a16="http://schemas.microsoft.com/office/drawing/2014/main" id="{E2B383A4-ECEF-4127-93A5-420B58468303}"/>
+                  </a:ext>
+                </a:extLst>
+              </p:cNvPr>
+              <p:cNvSpPr/>
+              <p:nvPr/>
+            </p:nvSpPr>
+            <p:spPr>
+              <a:xfrm>
+                <a:off x="13379979" y="3290137"/>
+                <a:ext cx="2616200" cy="1405368"/>
+              </a:xfrm>
+              <a:prstGeom prst="roundRect">
+                <a:avLst/>
+              </a:prstGeom>
+              <a:solidFill>
+                <a:srgbClr val="0B5852"/>
+              </a:solidFill>
+              <a:ln>
+                <a:noFill/>
+              </a:ln>
+            </p:spPr>
+            <p:style>
+              <a:lnRef idx="2">
+                <a:schemeClr val="accent1">
+                  <a:shade val="50000"/>
+                </a:schemeClr>
+              </a:lnRef>
+              <a:fillRef idx="1">
+                <a:schemeClr val="accent1"/>
+              </a:fillRef>
+              <a:effectRef idx="0">
+                <a:schemeClr val="accent1"/>
+              </a:effectRef>
+              <a:fontRef idx="minor">
+                <a:schemeClr val="lt1"/>
+              </a:fontRef>
+            </p:style>
+            <p:txBody>
+              <a:bodyPr rtlCol="0" anchor="ctr"/>
+              <a:lstStyle/>
+              <a:p>
+                <a:pPr algn="ctr"/>
+                <a:r>
+                  <a:rPr lang="en-US" sz="4400" dirty="0">
+                    <a:latin typeface="Cambria" panose="02040503050406030204" pitchFamily="18" charset="0"/>
+                    <a:ea typeface="Cambria" panose="02040503050406030204" pitchFamily="18" charset="0"/>
+                  </a:rPr>
+                  <a:t>VoxCPM2</a:t>
+                </a:r>
+              </a:p>
+            </p:txBody>
+          </p:sp>
+          <p:sp>
+            <p:nvSpPr>
+              <p:cNvPr id="14" name="Text 15">
+                <a:extLst>
+                  <a:ext uri="{FF2B5EF4-FFF2-40B4-BE49-F238E27FC236}">
+                    <a16:creationId xmlns:a16="http://schemas.microsoft.com/office/drawing/2014/main" id="{A0B23DEA-CCDE-468A-85CC-A4782DA7F642}"/>
+                  </a:ext>
+                </a:extLst>
+              </p:cNvPr>
+              <p:cNvSpPr/>
+              <p:nvPr/>
+            </p:nvSpPr>
+            <p:spPr>
+              <a:xfrm>
+                <a:off x="13679784" y="5370245"/>
+                <a:ext cx="2016592" cy="283552"/>
+              </a:xfrm>
+              <a:prstGeom prst="rect">
+                <a:avLst/>
+              </a:prstGeom>
+              <a:noFill/>
+              <a:ln/>
+            </p:spPr>
+            <p:txBody>
+              <a:bodyPr wrap="square" lIns="25400" tIns="25400" rIns="25400" bIns="25400" rtlCol="0" anchor="t">
+                <a:normAutofit/>
+              </a:bodyPr>
+              <a:lstStyle/>
+              <a:p>
+                <a:pPr algn="just">
+                  <a:lnSpc>
+                    <a:spcPct val="114853"/>
+                  </a:lnSpc>
+                </a:pPr>
+                <a:r>
+                  <a:rPr lang="en-US" sz="1600" dirty="0">
+                    <a:solidFill>
+                      <a:schemeClr val="bg2">
+                        <a:lumMod val="25000"/>
+                      </a:schemeClr>
+                    </a:solidFill>
+                    <a:latin typeface="Cambria" panose="02040503050406030204" pitchFamily="18" charset="0"/>
+                    <a:ea typeface="Cambria" panose="02040503050406030204" pitchFamily="18" charset="0"/>
+                  </a:rPr>
+                  <a:t>The fox jump over the fence…</a:t>
+                </a:r>
+              </a:p>
+            </p:txBody>
+          </p:sp>
+          <p:cxnSp>
+            <p:nvCxnSpPr>
+              <p:cNvPr id="18" name="Connector: Elbow 17">
+                <a:extLst>
+                  <a:ext uri="{FF2B5EF4-FFF2-40B4-BE49-F238E27FC236}">
+                    <a16:creationId xmlns:a16="http://schemas.microsoft.com/office/drawing/2014/main" id="{F6FAC2D9-1974-4944-9576-84E814DD37BE}"/>
+                  </a:ext>
+                </a:extLst>
+              </p:cNvPr>
+              <p:cNvCxnSpPr>
+                <a:cxnSpLocks/>
+                <a:stCxn id="14" idx="0"/>
+                <a:endCxn id="13" idx="2"/>
+              </p:cNvCxnSpPr>
+              <p:nvPr/>
+            </p:nvCxnSpPr>
+            <p:spPr>
+              <a:xfrm rot="16200000" flipV="1">
+                <a:off x="14350709" y="5032874"/>
+                <a:ext cx="674740" cy="1"/>
+              </a:xfrm>
+              <a:prstGeom prst="bentConnector3">
+                <a:avLst>
+                  <a:gd name="adj1" fmla="val 50000"/>
+                </a:avLst>
+              </a:prstGeom>
+              <a:ln>
+                <a:solidFill>
+                  <a:srgbClr val="0B5852"/>
+                </a:solidFill>
+                <a:tailEnd type="triangle"/>
+              </a:ln>
+            </p:spPr>
+            <p:style>
+              <a:lnRef idx="1">
+                <a:schemeClr val="accent1"/>
+              </a:lnRef>
+              <a:fillRef idx="0">
+                <a:schemeClr val="accent1"/>
+              </a:fillRef>
+              <a:effectRef idx="0">
+                <a:schemeClr val="accent1"/>
+              </a:effectRef>
+              <a:fontRef idx="minor">
+                <a:schemeClr val="tx1"/>
+              </a:fontRef>
+            </p:style>
+          </p:cxnSp>
+          <p:pic>
+            <p:nvPicPr>
+              <p:cNvPr id="20" name="Graphic 19">
+                <a:extLst>
+                  <a:ext uri="{FF2B5EF4-FFF2-40B4-BE49-F238E27FC236}">
+                    <a16:creationId xmlns:a16="http://schemas.microsoft.com/office/drawing/2014/main" id="{20AAEAB1-1696-4382-9504-1DAFB293D1EC}"/>
+                  </a:ext>
+                </a:extLst>
+              </p:cNvPr>
+              <p:cNvPicPr>
+                <a:picLocks noChangeAspect="1"/>
+              </p:cNvPicPr>
+              <p:nvPr/>
+            </p:nvPicPr>
+            <p:blipFill>
+              <a:blip r:embed="rId3">
+                <a:extLst>
+                  <a:ext uri="{96DAC541-7B7A-43D3-8B79-37D633B846F1}">
+                    <asvg:svgBlip xmlns:asvg="http://schemas.microsoft.com/office/drawing/2016/SVG/main" r:embed="rId4"/>
+                  </a:ext>
+                  <a:ext uri="{837473B0-CC2E-450A-ABE3-18F120FF3D39}">
+                    <a1611:picAttrSrcUrl xmlns:a1611="http://schemas.microsoft.com/office/drawing/2016/11/main" r:id="rId5"/>
+                  </a:ext>
+                </a:extLst>
+              </a:blip>
+              <a:stretch>
+                <a:fillRect/>
+              </a:stretch>
+            </p:blipFill>
+            <p:spPr>
+              <a:xfrm>
+                <a:off x="11579560" y="3712043"/>
+                <a:ext cx="1038258" cy="554711"/>
+              </a:xfrm>
+              <a:prstGeom prst="rect">
+                <a:avLst/>
+              </a:prstGeom>
+            </p:spPr>
+          </p:pic>
+          <p:cxnSp>
+            <p:nvCxnSpPr>
+              <p:cNvPr id="21" name="Straight Arrow Connector 20">
+                <a:extLst>
+                  <a:ext uri="{FF2B5EF4-FFF2-40B4-BE49-F238E27FC236}">
+                    <a16:creationId xmlns:a16="http://schemas.microsoft.com/office/drawing/2014/main" id="{CB7F2C4C-3078-4ECE-A1E2-4E78BD993DA8}"/>
+                  </a:ext>
+                </a:extLst>
+              </p:cNvPr>
+              <p:cNvCxnSpPr>
+                <a:cxnSpLocks/>
+                <a:stCxn id="20" idx="3"/>
+                <a:endCxn id="13" idx="1"/>
+              </p:cNvCxnSpPr>
+              <p:nvPr/>
+            </p:nvCxnSpPr>
+            <p:spPr>
+              <a:xfrm>
+                <a:off x="12617818" y="3989399"/>
+                <a:ext cx="762161" cy="3422"/>
+              </a:xfrm>
+              <a:prstGeom prst="straightConnector1">
+                <a:avLst/>
+              </a:prstGeom>
+              <a:ln>
+                <a:solidFill>
+                  <a:srgbClr val="0B5852"/>
+                </a:solidFill>
+                <a:tailEnd type="triangle"/>
+              </a:ln>
+            </p:spPr>
+            <p:style>
+              <a:lnRef idx="1">
+                <a:schemeClr val="accent1"/>
+              </a:lnRef>
+              <a:fillRef idx="0">
+                <a:schemeClr val="accent1"/>
+              </a:fillRef>
+              <a:effectRef idx="0">
+                <a:schemeClr val="accent1"/>
+              </a:effectRef>
+              <a:fontRef idx="minor">
+                <a:schemeClr val="tx1"/>
+              </a:fontRef>
+            </p:style>
+          </p:cxnSp>
+          <p:pic>
+            <p:nvPicPr>
+              <p:cNvPr id="22" name="Graphic 21">
+                <a:extLst>
+                  <a:ext uri="{FF2B5EF4-FFF2-40B4-BE49-F238E27FC236}">
+                    <a16:creationId xmlns:a16="http://schemas.microsoft.com/office/drawing/2014/main" id="{AE3CEBD9-C146-400B-85EC-5D31CB94C598}"/>
+                  </a:ext>
+                </a:extLst>
+              </p:cNvPr>
+              <p:cNvPicPr>
+                <a:picLocks noChangeAspect="1"/>
+              </p:cNvPicPr>
+              <p:nvPr/>
+            </p:nvPicPr>
+            <p:blipFill>
+              <a:blip r:embed="rId3">
+                <a:extLst>
+                  <a:ext uri="{96DAC541-7B7A-43D3-8B79-37D633B846F1}">
+                    <asvg:svgBlip xmlns:asvg="http://schemas.microsoft.com/office/drawing/2016/SVG/main" r:embed="rId4"/>
+                  </a:ext>
+                  <a:ext uri="{837473B0-CC2E-450A-ABE3-18F120FF3D39}">
+                    <a1611:picAttrSrcUrl xmlns:a1611="http://schemas.microsoft.com/office/drawing/2016/11/main" r:id="rId5"/>
+                  </a:ext>
+                </a:extLst>
+              </a:blip>
+              <a:stretch>
+                <a:fillRect/>
+              </a:stretch>
+            </p:blipFill>
+            <p:spPr>
+              <a:xfrm>
+                <a:off x="14168950" y="1968091"/>
+                <a:ext cx="1038258" cy="554711"/>
+              </a:xfrm>
+              <a:prstGeom prst="rect">
+                <a:avLst/>
+              </a:prstGeom>
+            </p:spPr>
+          </p:pic>
+          <p:cxnSp>
+            <p:nvCxnSpPr>
+              <p:cNvPr id="23" name="Straight Arrow Connector 22">
+                <a:extLst>
+                  <a:ext uri="{FF2B5EF4-FFF2-40B4-BE49-F238E27FC236}">
+                    <a16:creationId xmlns:a16="http://schemas.microsoft.com/office/drawing/2014/main" id="{A4D5ADD3-4373-4237-A11B-1E277C6324DD}"/>
+                  </a:ext>
+                </a:extLst>
+              </p:cNvPr>
+              <p:cNvCxnSpPr>
+                <a:cxnSpLocks/>
+                <a:stCxn id="13" idx="0"/>
+                <a:endCxn id="22" idx="2"/>
+              </p:cNvCxnSpPr>
+              <p:nvPr/>
+            </p:nvCxnSpPr>
+            <p:spPr>
+              <a:xfrm flipV="1">
+                <a:off x="14688079" y="2522802"/>
+                <a:ext cx="0" cy="767335"/>
+              </a:xfrm>
+              <a:prstGeom prst="straightConnector1">
+                <a:avLst/>
+              </a:prstGeom>
+              <a:ln>
+                <a:solidFill>
+                  <a:srgbClr val="0B5852"/>
+                </a:solidFill>
+                <a:tailEnd type="triangle"/>
+              </a:ln>
+            </p:spPr>
+            <p:style>
+              <a:lnRef idx="1">
+                <a:schemeClr val="accent1"/>
+              </a:lnRef>
+              <a:fillRef idx="0">
+                <a:schemeClr val="accent1"/>
+              </a:fillRef>
+              <a:effectRef idx="0">
+                <a:schemeClr val="accent1"/>
+              </a:effectRef>
+              <a:fontRef idx="minor">
+                <a:schemeClr val="tx1"/>
+              </a:fontRef>
+            </p:style>
+          </p:cxnSp>
+          <p:sp>
+            <p:nvSpPr>
+              <p:cNvPr id="24" name="Text 15">
+                <a:extLst>
+                  <a:ext uri="{FF2B5EF4-FFF2-40B4-BE49-F238E27FC236}">
+                    <a16:creationId xmlns:a16="http://schemas.microsoft.com/office/drawing/2014/main" id="{6C975829-1ED6-4296-93A3-0978A83159AD}"/>
+                  </a:ext>
+                </a:extLst>
+              </p:cNvPr>
+              <p:cNvSpPr/>
+              <p:nvPr/>
+            </p:nvSpPr>
+            <p:spPr>
+              <a:xfrm>
+                <a:off x="14813009" y="2522802"/>
+                <a:ext cx="653763" cy="283551"/>
+              </a:xfrm>
+              <a:prstGeom prst="rect">
+                <a:avLst/>
+              </a:prstGeom>
+              <a:noFill/>
+              <a:ln/>
+            </p:spPr>
+            <p:txBody>
+              <a:bodyPr wrap="square" lIns="25400" tIns="25400" rIns="25400" bIns="25400" rtlCol="0" anchor="t">
+                <a:noAutofit/>
+              </a:bodyPr>
+              <a:lstStyle/>
+              <a:p>
+                <a:pPr algn="just">
+                  <a:lnSpc>
+                    <a:spcPct val="114853"/>
+                  </a:lnSpc>
+                </a:pPr>
+                <a:r>
+                  <a:rPr lang="en-US" sz="1600" i="1" dirty="0">
+                    <a:solidFill>
+                      <a:schemeClr val="bg2">
+                        <a:lumMod val="75000"/>
+                      </a:schemeClr>
+                    </a:solidFill>
+                    <a:latin typeface="Cambria" panose="02040503050406030204" pitchFamily="18" charset="0"/>
+                    <a:ea typeface="Cambria" panose="02040503050406030204" pitchFamily="18" charset="0"/>
+                  </a:rPr>
+                  <a:t>Output</a:t>
+                </a:r>
+              </a:p>
+            </p:txBody>
+          </p:sp>
+          <p:sp>
+            <p:nvSpPr>
+              <p:cNvPr id="25" name="Text 15">
+                <a:extLst>
+                  <a:ext uri="{FF2B5EF4-FFF2-40B4-BE49-F238E27FC236}">
+                    <a16:creationId xmlns:a16="http://schemas.microsoft.com/office/drawing/2014/main" id="{B3FBF4F5-A02F-4553-A0BB-E554F3D9C415}"/>
+                  </a:ext>
+                </a:extLst>
+              </p:cNvPr>
+              <p:cNvSpPr/>
+              <p:nvPr/>
+            </p:nvSpPr>
+            <p:spPr>
+              <a:xfrm>
+                <a:off x="11579560" y="4276372"/>
+                <a:ext cx="1038259" cy="283551"/>
+              </a:xfrm>
+              <a:prstGeom prst="rect">
+                <a:avLst/>
+              </a:prstGeom>
+              <a:noFill/>
+              <a:ln/>
+            </p:spPr>
+            <p:txBody>
+              <a:bodyPr wrap="square" lIns="25400" tIns="25400" rIns="25400" bIns="25400" rtlCol="0" anchor="t">
+                <a:noAutofit/>
+              </a:bodyPr>
+              <a:lstStyle/>
+              <a:p>
+                <a:pPr algn="just">
+                  <a:lnSpc>
+                    <a:spcPct val="114853"/>
+                  </a:lnSpc>
+                </a:pPr>
+                <a:r>
+                  <a:rPr lang="en-US" sz="1600" i="1" dirty="0">
+                    <a:solidFill>
+                      <a:schemeClr val="bg2">
+                        <a:lumMod val="75000"/>
+                      </a:schemeClr>
+                    </a:solidFill>
+                    <a:latin typeface="Cambria" panose="02040503050406030204" pitchFamily="18" charset="0"/>
+                    <a:ea typeface="Cambria" panose="02040503050406030204" pitchFamily="18" charset="0"/>
+                  </a:rPr>
+                  <a:t>Reference Clips</a:t>
+                </a:r>
+              </a:p>
+            </p:txBody>
+          </p:sp>
+        </p:grpSp>
+        <p:sp>
+          <p:nvSpPr>
+            <p:cNvPr id="30" name="Text 15">
+              <a:extLst>
+                <a:ext uri="{FF2B5EF4-FFF2-40B4-BE49-F238E27FC236}">
+                  <a16:creationId xmlns:a16="http://schemas.microsoft.com/office/drawing/2014/main" id="{C7CDEA75-280B-4F4B-B919-470E162CA92A}"/>
+                </a:ext>
+              </a:extLst>
+            </p:cNvPr>
+            <p:cNvSpPr/>
+            <p:nvPr/>
+          </p:nvSpPr>
+          <p:spPr>
+            <a:xfrm>
+              <a:off x="12892999" y="6802403"/>
+              <a:ext cx="1424428" cy="389014"/>
+            </a:xfrm>
+            <a:prstGeom prst="rect">
+              <a:avLst/>
+            </a:prstGeom>
+            <a:noFill/>
+            <a:ln/>
+          </p:spPr>
+          <p:txBody>
+            <a:bodyPr wrap="square" lIns="25400" tIns="25400" rIns="25400" bIns="25400" rtlCol="0" anchor="t">
+              <a:noAutofit/>
+            </a:bodyPr>
+            <a:lstStyle/>
+            <a:p>
+              <a:pPr algn="ctr">
+                <a:lnSpc>
+                  <a:spcPct val="114853"/>
+                </a:lnSpc>
+              </a:pPr>
+              <a:r>
+                <a:rPr lang="en-US" sz="1600" i="1" dirty="0">
+                  <a:solidFill>
+                    <a:schemeClr val="bg2">
+                      <a:lumMod val="75000"/>
+                    </a:schemeClr>
+                  </a:solidFill>
+                  <a:latin typeface="Cambria" panose="02040503050406030204" pitchFamily="18" charset="0"/>
+                  <a:ea typeface="Cambria" panose="02040503050406030204" pitchFamily="18" charset="0"/>
+                </a:rPr>
+                <a:t>Text Input</a:t>
+              </a:r>
+            </a:p>
+          </p:txBody>
+        </p:sp>
+      </p:grpSp>
+      <p:sp>
+        <p:nvSpPr>
+          <p:cNvPr id="31" name="Text 15">
+            <a:extLst>
+              <a:ext uri="{FF2B5EF4-FFF2-40B4-BE49-F238E27FC236}">
+                <a16:creationId xmlns:a16="http://schemas.microsoft.com/office/drawing/2014/main" id="{08ED5943-2718-44DD-8488-893764E38D14}"/>
+              </a:ext>
+            </a:extLst>
+          </p:cNvPr>
+          <p:cNvSpPr/>
+          <p:nvPr/>
+        </p:nvSpPr>
+        <p:spPr>
+          <a:xfrm>
+            <a:off x="7499797" y="3954579"/>
+            <a:ext cx="8390173" cy="4553712"/>
+          </a:xfrm>
+          <a:prstGeom prst="rect">
+            <a:avLst/>
+          </a:prstGeom>
+          <a:noFill/>
+          <a:ln/>
+        </p:spPr>
+        <p:txBody>
+          <a:bodyPr wrap="square" lIns="25400" tIns="25400" rIns="25400" bIns="25400" rtlCol="0" anchor="t">
+            <a:normAutofit/>
+          </a:bodyPr>
+          <a:lstStyle/>
+          <a:p>
+            <a:pPr algn="just">
+              <a:lnSpc>
+                <a:spcPct val="114853"/>
+              </a:lnSpc>
+            </a:pPr>
+            <a:r>
+              <a:rPr lang="en-US" sz="2000" dirty="0">
+                <a:solidFill>
+                  <a:schemeClr val="bg2">
+                    <a:lumMod val="25000"/>
+                  </a:schemeClr>
+                </a:solidFill>
+                <a:latin typeface="Cambria" panose="02040503050406030204" pitchFamily="18" charset="0"/>
+                <a:ea typeface="Cambria" panose="02040503050406030204" pitchFamily="18" charset="0"/>
+              </a:rPr>
+              <a:t>VoxCPM2 is able to take a reference clip as input, and copy the exact style of speaking, and apply it on a completely different text. Depending on how expressive the reference clips are, VoxCPM2 is able to adapt to the modulation within the reference clips.</a:t>
+            </a:r>
+          </a:p>
+          <a:p>
+            <a:pPr algn="just">
+              <a:lnSpc>
+                <a:spcPct val="114853"/>
+              </a:lnSpc>
+            </a:pPr>
+            <a:endParaRPr lang="en-US" sz="2000" dirty="0">
+              <a:solidFill>
+                <a:schemeClr val="bg2">
+                  <a:lumMod val="25000"/>
+                </a:schemeClr>
+              </a:solidFill>
+              <a:latin typeface="Cambria" panose="02040503050406030204" pitchFamily="18" charset="0"/>
+              <a:ea typeface="Cambria" panose="02040503050406030204" pitchFamily="18" charset="0"/>
+            </a:endParaRPr>
+          </a:p>
+          <a:p>
+            <a:pPr algn="just">
+              <a:lnSpc>
+                <a:spcPct val="114853"/>
+              </a:lnSpc>
+            </a:pPr>
+            <a:r>
+              <a:rPr lang="en-US" sz="2000" dirty="0">
+                <a:solidFill>
+                  <a:schemeClr val="bg2">
+                    <a:lumMod val="25000"/>
+                  </a:schemeClr>
+                </a:solidFill>
+                <a:latin typeface="Cambria" panose="02040503050406030204" pitchFamily="18" charset="0"/>
+                <a:ea typeface="Cambria" panose="02040503050406030204" pitchFamily="18" charset="0"/>
+              </a:rPr>
+              <a:t>However, this method main limitation is that VoxCPM2 voice mimic whoever is in the reference clips, making it restrictive for user who wished to use a different voice.</a:t>
+            </a:r>
+          </a:p>
+        </p:txBody>
+      </p:sp>
+      <p:sp>
+        <p:nvSpPr>
+          <p:cNvPr id="32" name="Text 15">
+            <a:extLst>
+              <a:ext uri="{FF2B5EF4-FFF2-40B4-BE49-F238E27FC236}">
+                <a16:creationId xmlns:a16="http://schemas.microsoft.com/office/drawing/2014/main" id="{28AB3AB6-99CB-4D79-A85C-8190E81A3666}"/>
+              </a:ext>
+            </a:extLst>
+          </p:cNvPr>
+          <p:cNvSpPr/>
+          <p:nvPr/>
+        </p:nvSpPr>
+        <p:spPr>
+          <a:xfrm>
+            <a:off x="7499797" y="9204841"/>
+            <a:ext cx="9869714" cy="389016"/>
+          </a:xfrm>
+          <a:prstGeom prst="rect">
+            <a:avLst/>
+          </a:prstGeom>
+          <a:noFill/>
+          <a:ln/>
+        </p:spPr>
+        <p:txBody>
+          <a:bodyPr wrap="square" lIns="25400" tIns="25400" rIns="25400" bIns="25400" rtlCol="0" anchor="t">
+            <a:noAutofit/>
+          </a:bodyPr>
+          <a:lstStyle/>
+          <a:p>
+            <a:pPr algn="just">
+              <a:lnSpc>
+                <a:spcPct val="114853"/>
+              </a:lnSpc>
+            </a:pPr>
+            <a:r>
+              <a:rPr lang="en-US" sz="2000" i="1" dirty="0">
+                <a:solidFill>
+                  <a:schemeClr val="bg2">
+                    <a:lumMod val="75000"/>
+                  </a:schemeClr>
+                </a:solidFill>
+                <a:latin typeface="Cambria" panose="02040503050406030204" pitchFamily="18" charset="0"/>
+                <a:ea typeface="Cambria" panose="02040503050406030204" pitchFamily="18" charset="0"/>
+              </a:rPr>
+              <a:t>Sample audio can be listened </a:t>
+            </a:r>
+            <a:r>
+              <a:rPr lang="en-US" sz="2000" i="1" dirty="0">
+                <a:solidFill>
+                  <a:schemeClr val="bg2">
+                    <a:lumMod val="75000"/>
+                  </a:schemeClr>
+                </a:solidFill>
+                <a:latin typeface="Cambria" panose="02040503050406030204" pitchFamily="18" charset="0"/>
+                <a:ea typeface="Cambria" panose="02040503050406030204" pitchFamily="18" charset="0"/>
+                <a:hlinkClick r:id="rId6"/>
+              </a:rPr>
+              <a:t>here</a:t>
+            </a:r>
+            <a:endParaRPr lang="en-US" sz="2000" i="1" dirty="0">
+              <a:solidFill>
+                <a:schemeClr val="bg2">
+                  <a:lumMod val="75000"/>
+                </a:schemeClr>
+              </a:solidFill>
+              <a:latin typeface="Cambria" panose="02040503050406030204" pitchFamily="18" charset="0"/>
+              <a:ea typeface="Cambria" panose="02040503050406030204" pitchFamily="18" charset="0"/>
+            </a:endParaRPr>
+          </a:p>
+        </p:txBody>
+      </p:sp>
+    </p:spTree>
+    <p:extLst>
+      <p:ext uri="{BB962C8B-B14F-4D97-AF65-F5344CB8AC3E}">
+        <p14:creationId xmlns:p14="http://schemas.microsoft.com/office/powerpoint/2010/main" val="3861179402"/>
+      </p:ext>
+    </p:extLst>
+  </p:cSld>
+  <p:clrMapOvr>
+    <a:masterClrMapping/>
+  </p:clrMapOvr>
+</p:sld>
+</file>
+
+<file path=ppt/slides/slide8.xml><?xml version="1.0" encoding="utf-8"?>
+<p:sld xmlns:a="http://schemas.openxmlformats.org/drawingml/2006/main" xmlns:r="http://schemas.openxmlformats.org/officeDocument/2006/relationships" xmlns:p="http://schemas.openxmlformats.org/presentationml/2006/main">
+  <p:cSld>
+    <p:bg>
+      <p:bgPr>
+        <a:solidFill>
+          <a:srgbClr val="FAF8F4"/>
+        </a:solidFill>
+        <a:effectLst/>
+      </p:bgPr>
+    </p:bg>
+    <p:spTree>
+      <p:nvGrpSpPr>
+        <p:cNvPr id="1" name=""/>
+        <p:cNvGrpSpPr/>
+        <p:nvPr/>
+      </p:nvGrpSpPr>
+      <p:grpSpPr>
+        <a:xfrm>
+          <a:off x="0" y="0"/>
+          <a:ext cx="0" cy="0"/>
+          <a:chOff x="0" y="0"/>
+          <a:chExt cx="0" cy="0"/>
+        </a:xfrm>
+      </p:grpSpPr>
+      <p:grpSp>
+        <p:nvGrpSpPr>
+          <p:cNvPr id="3" name="Group 2">
+            <a:extLst>
+              <a:ext uri="{FF2B5EF4-FFF2-40B4-BE49-F238E27FC236}">
+                <a16:creationId xmlns:a16="http://schemas.microsoft.com/office/drawing/2014/main" id="{CE41674B-3A28-4A10-BE8B-919C3E3A4D31}"/>
+              </a:ext>
+            </a:extLst>
+          </p:cNvPr>
+          <p:cNvGrpSpPr/>
+          <p:nvPr/>
+        </p:nvGrpSpPr>
+        <p:grpSpPr>
+          <a:xfrm>
+            <a:off x="688508" y="832167"/>
+            <a:ext cx="13622578" cy="867471"/>
+            <a:chOff x="5550794" y="437377"/>
+            <a:chExt cx="11230589" cy="867471"/>
+          </a:xfrm>
+        </p:grpSpPr>
+        <p:sp>
+          <p:nvSpPr>
+            <p:cNvPr id="36" name="Text 10">
+              <a:extLst>
+                <a:ext uri="{FF2B5EF4-FFF2-40B4-BE49-F238E27FC236}">
+                  <a16:creationId xmlns:a16="http://schemas.microsoft.com/office/drawing/2014/main" id="{653710F3-73F0-4CC1-9253-3E1A5D14AAF0}"/>
+                </a:ext>
+              </a:extLst>
+            </p:cNvPr>
+            <p:cNvSpPr/>
+            <p:nvPr/>
+          </p:nvSpPr>
+          <p:spPr>
+            <a:xfrm>
+              <a:off x="5550794" y="437377"/>
+              <a:ext cx="11230589" cy="820856"/>
+            </a:xfrm>
+            <a:prstGeom prst="rect">
+              <a:avLst/>
+            </a:prstGeom>
+            <a:noFill/>
+            <a:ln/>
+          </p:spPr>
+          <p:txBody>
+            <a:bodyPr wrap="square" lIns="25400" tIns="25400" rIns="25400" bIns="25400" rtlCol="0" anchor="t">
+              <a:noAutofit/>
+            </a:bodyPr>
+            <a:lstStyle/>
+            <a:p>
+              <a:pPr marL="0" indent="0" algn="l">
+                <a:lnSpc>
+                  <a:spcPct val="93867"/>
+                </a:lnSpc>
+                <a:buNone/>
+              </a:pPr>
+              <a:r>
+                <a:rPr lang="en-US" sz="4800" b="1" kern="0" spc="-36" dirty="0">
+                  <a:solidFill>
+                    <a:srgbClr val="0B5852"/>
+                  </a:solidFill>
+                  <a:latin typeface="Georgia" panose="02040502050405020303" pitchFamily="18" charset="0"/>
+                  <a:ea typeface="Barlow Condensed" pitchFamily="34" charset="-122"/>
+                </a:rPr>
+                <a:t>Recommendation</a:t>
+              </a:r>
+              <a:endParaRPr lang="en-US" sz="4800" b="1" dirty="0">
+                <a:latin typeface="Georgia" panose="02040502050405020303" pitchFamily="18" charset="0"/>
+              </a:endParaRPr>
+            </a:p>
+          </p:txBody>
+        </p:sp>
+        <p:sp>
+          <p:nvSpPr>
+            <p:cNvPr id="48" name="Shape 1">
+              <a:extLst>
+                <a:ext uri="{FF2B5EF4-FFF2-40B4-BE49-F238E27FC236}">
+                  <a16:creationId xmlns:a16="http://schemas.microsoft.com/office/drawing/2014/main" id="{D062D97B-2B0C-4CB5-8535-9E819970BA10}"/>
+                </a:ext>
+              </a:extLst>
+            </p:cNvPr>
+            <p:cNvSpPr/>
+            <p:nvPr/>
+          </p:nvSpPr>
+          <p:spPr>
+            <a:xfrm>
+              <a:off x="5550794" y="1258232"/>
+              <a:ext cx="7593708" cy="46616"/>
+            </a:xfrm>
+            <a:prstGeom prst="rect">
+              <a:avLst/>
+            </a:prstGeom>
+            <a:solidFill>
+              <a:srgbClr val="0B5852"/>
+            </a:solidFill>
+            <a:ln/>
+          </p:spPr>
+        </p:sp>
+      </p:grpSp>
+      <p:sp>
+        <p:nvSpPr>
+          <p:cNvPr id="87" name="Shape 0">
+            <a:extLst>
+              <a:ext uri="{FF2B5EF4-FFF2-40B4-BE49-F238E27FC236}">
+                <a16:creationId xmlns:a16="http://schemas.microsoft.com/office/drawing/2014/main" id="{D0E0CC4D-0857-4350-BEF7-5F0684DE29AA}"/>
+              </a:ext>
+            </a:extLst>
+          </p:cNvPr>
+          <p:cNvSpPr/>
+          <p:nvPr/>
+        </p:nvSpPr>
+        <p:spPr>
+          <a:xfrm>
+            <a:off x="0" y="9897984"/>
+            <a:ext cx="18288000" cy="389016"/>
+          </a:xfrm>
+          <a:prstGeom prst="rect">
+            <a:avLst/>
+          </a:prstGeom>
+          <a:solidFill>
+            <a:srgbClr val="083B37"/>
+          </a:solidFill>
+          <a:ln/>
+        </p:spPr>
+      </p:sp>
+    </p:spTree>
+    <p:extLst>
+      <p:ext uri="{BB962C8B-B14F-4D97-AF65-F5344CB8AC3E}">
+        <p14:creationId xmlns:p14="http://schemas.microsoft.com/office/powerpoint/2010/main" val="4097037485"/>
       </p:ext>
     </p:extLst>
   </p:cSld>

</xml_diff>